<commit_message>
Slides: badged PPTX of sd-04-045
</commit_message>
<xml_diff>
--- a/system-design-101/vi/lessons/sd-04-045/slides/sd-04-045.pptx
+++ b/system-design-101/vi/lessons/sd-04-045/slides/sd-04-045.pptx
@@ -10272,7 +10272,7 @@
               <a:buNone/>
             </a:pPr>
             <a:r>
-              <a:rPr lang="en-US" sz="1950" b="1" spc="198" kern="0" dirty="0">
+              <a:rPr lang="en-US" sz="1950" b="1" spc="223" kern="0" dirty="0">
                 <a:solidFill>
                   <a:srgbClr val="FF6A4D"/>
                 </a:solidFill>
@@ -10280,32 +10280,10 @@
                 <a:ea typeface="Be Vietnam Pro" pitchFamily="34" charset="-122"/>
                 <a:cs typeface="Be Vietnam Pro" pitchFamily="34" charset="-120"/>
               </a:rPr>
-              <a:t>CÂU</a:t>
-            </a:r>
-            <a:r>
-              <a:rPr lang="en-US" sz="1950" b="1" spc="227" kern="0" dirty="0">
-                <a:solidFill>
-                  <a:srgbClr val="FF6A4D"/>
-                </a:solidFill>
-                <a:latin typeface="Be Vietnam Pro" pitchFamily="34" charset="0"/>
-                <a:ea typeface="Be Vietnam Pro" pitchFamily="34" charset="-122"/>
-                <a:cs typeface="Be Vietnam Pro" pitchFamily="34" charset="-120"/>
-              </a:rPr>
-              <a:t> HỎI</a:t>
-            </a:r>
-            <a:r>
-              <a:rPr lang="en-US" sz="1950" b="1" spc="222" kern="0" dirty="0">
-                <a:solidFill>
-                  <a:srgbClr val="FF6A4D"/>
-                </a:solidFill>
-                <a:latin typeface="Be Vietnam Pro" pitchFamily="34" charset="0"/>
-                <a:ea typeface="Be Vietnam Pro" pitchFamily="34" charset="-122"/>
-                <a:cs typeface="Be Vietnam Pro" pitchFamily="34" charset="-120"/>
-              </a:rPr>
-              <a:t> KIỂM</a:t>
-            </a:r>
-            <a:r>
-              <a:rPr lang="en-US" sz="1950" b="1" spc="225" kern="0" dirty="0">
+              <a:t>KIỂM</a:t>
+            </a:r>
+            <a:r>
+              <a:rPr lang="en-US" sz="1950" b="1" spc="224" kern="0" dirty="0">
                 <a:solidFill>
                   <a:srgbClr val="FF6A4D"/>
                 </a:solidFill>

</xml_diff>